<commit_message>
chore: publish branch work in .agents/plugins, .agents/skills, .github/ISSUE_TEMPLATE, … (901 files)
</commit_message>
<xml_diff>
--- a/packages/creative-context/src/eval/fixtures/launch-system-v1.pptx
+++ b/packages/creative-context/src/eval/fixtures/launch-system-v1.pptx
@@ -198,9 +198,9 @@
 </file>
 
 <file path=ppt/theme/theme1.xml><?xml version="1.0" encoding="utf-8"?>
-<a:theme xmlns:a="http://schemas.openxmlformats.org/drawingml/2006/main" name="Agent Native">
+<a:theme xmlns:a="http://schemas.openxmlformats.org/drawingml/2006/main" name="Agent-Native">
   <a:themeElements>
-    <a:clrScheme name="Agent Native">
+    <a:clrScheme name="Agent-Native">
       <a:dk1>
         <a:srgbClr val="0B0B10"/>
       </a:dk1>
@@ -211,7 +211,7 @@
         <a:srgbClr val="FFFFFF"/>
       </a:lt1>
     </a:clrScheme>
-    <a:fontScheme name="Agent Native">
+    <a:fontScheme name="Agent-Native">
       <a:majorFont>
         <a:latin typeface="Inter"/>
       </a:majorFont>

</xml_diff>

<commit_message>
fix: standardize Agent-Native branding (#3655)
* chore: publish branch work in .changeset/notion-oauth-client-deploy-env.md, packages/core, templates/content (4 files)

* chore: publish branch work in .agents/plugins, .agents/skills, .github/ISSUE_TEMPLATE, … (901 files)

* chore: publish branch work in package.json, packages/desktop-app, packages/docs, … (13 files)

* chore: publish branch work in packages/desktop-app (3 files)

* chore: publish branch work in .changeset/dashed-agent-native-brand.md (1 files)

* chore: publish branch work in packages/core, packages/desktop-app (13 files)

* chore: publish branch work in .changeset/dashed-agent-native-brand.md (1 files)
</commit_message>
<xml_diff>
--- a/packages/creative-context/src/eval/fixtures/launch-system-v1.pptx
+++ b/packages/creative-context/src/eval/fixtures/launch-system-v1.pptx
@@ -198,9 +198,9 @@
 </file>
 
 <file path=ppt/theme/theme1.xml><?xml version="1.0" encoding="utf-8"?>
-<a:theme xmlns:a="http://schemas.openxmlformats.org/drawingml/2006/main" name="Agent Native">
+<a:theme xmlns:a="http://schemas.openxmlformats.org/drawingml/2006/main" name="Agent-Native">
   <a:themeElements>
-    <a:clrScheme name="Agent Native">
+    <a:clrScheme name="Agent-Native">
       <a:dk1>
         <a:srgbClr val="0B0B10"/>
       </a:dk1>
@@ -211,7 +211,7 @@
         <a:srgbClr val="FFFFFF"/>
       </a:lt1>
     </a:clrScheme>
-    <a:fontScheme name="Agent Native">
+    <a:fontScheme name="Agent-Native">
       <a:majorFont>
         <a:latin typeface="Inter"/>
       </a:majorFont>

</xml_diff>